<commit_message>
fix(bankroll): format negative dollars as −$427 in the deck
Slide 6's worst-week row printed "$-427".

Co-Authored-By: Claude Fable 5.1 <noreply@anthropic.com>
</commit_message>
<xml_diff>
--- a/research/bankroll/docs/seed-bankroll-proposal-2026-09-17.pptx
+++ b/research/bankroll/docs/seed-bankroll-proposal-2026-09-17.pptx
@@ -5106,7 +5106,7 @@
                         </a:defRPr>
                       </a:pPr>
                       <a:r>
-                        <a:t>$-427</a:t>
+                        <a:t>−$427</a:t>
                       </a:r>
                     </a:p>
                   </a:txBody>
@@ -5125,7 +5125,7 @@
                         </a:defRPr>
                       </a:pPr>
                       <a:r>
-                        <a:t>$-442</a:t>
+                        <a:t>−$442</a:t>
                       </a:r>
                     </a:p>
                   </a:txBody>

</xml_diff>

<commit_message>
feat(bankroll): Greenline volume follows the FBS-vs-FBS slate, resweep
Greenline flags every FBS-vs-FBS game (week 2: 49 games, 49 flags;
week 3: 57 and 57), so the weekly flag count is the schedule, not a
constant 49. GL_FLAGS_BY_WEEK carries the 2026 counts for weeks 4-13
from core.fact_game and 2025's for weeks 14-15: ~680 flags, not 588.
--gl-volume slate is the default; constant reproduces the earlier
tables and the MC doc says so.

Resweep at 50k paths: recommended row unchanged at 0.5% x 13%
(median $20,821 pooled / $20,594 n49, P(-25%) 0 under both). Every
coverage row above 13% now fails the risk limit under the n49 prior
except 0.25% x 25%, which earns less. Proposal, growth doc, deck and
PDF carry the new numbers; ~88 Greenline bets, ~7 a week.

Co-Authored-By: Claude Fable 5.1 <noreply@anthropic.com>
</commit_message>
<xml_diff>
--- a/research/bankroll/docs/seed-bankroll-proposal-2026-09-17.pptx
+++ b/research/bankroll/docs/seed-bankroll-proposal-2026-09-17.pptx
@@ -3510,7 +3510,7 @@
                         </a:defRPr>
                       </a:pPr>
                       <a:r>
-                        <a:t>~87: ~76 Greenline unders, ~11 over-zero overs</a:t>
+                        <a:t>~99: ~88 Greenline unders, ~11 over-zero overs</a:t>
                       </a:r>
                     </a:p>
                   </a:txBody>
@@ -4062,7 +4062,7 @@
                         </a:defRPr>
                       </a:pPr>
                       <a:r>
-                        <a:t>~6 a week, ~76 total</a:t>
+                        <a:t>~13% of each week's flags, ~7 a week, ~88 total</a:t>
                       </a:r>
                     </a:p>
                   </a:txBody>
@@ -4469,7 +4469,7 @@
               </a:defRPr>
             </a:pPr>
             <a:r>
-              <a:t>Median $20,727 pooled / $20,542 2026-only.</a:t>
+              <a:t>Median $20,821 pooled / $20,594 2026-only.</a:t>
             </a:r>
           </a:p>
           <a:p>
@@ -4484,7 +4484,7 @@
               </a:defRPr>
             </a:pPr>
             <a:r>
-              <a:t>5th pct $18,773 / $18,060. P(−25%) 0% under both.</a:t>
+              <a:t>5th pct $18,685 / $17,818. P(−25%) 0% under both.</a:t>
             </a:r>
           </a:p>
           <a:p>
@@ -4511,7 +4511,7 @@
               </a:defRPr>
             </a:pPr>
             <a:r>
-              <a:t>1% ($200) passes only under the pooled prior (median $21,315 / $20,936; P(−25%) 0.2% / 1.9%). Upgrade path once four more weeks are graded.</a:t>
+              <a:t>1% ($200) passes only under the pooled prior (median $21,502 / $21,052; P(−25%) 0.4% / 3.0%). Upgrade path once four more weeks are graded.</a:t>
             </a:r>
           </a:p>
           <a:p>
@@ -4752,7 +4752,7 @@
                         </a:defRPr>
                       </a:pPr>
                       <a:r>
-                        <a:t>27.0%</a:t>
+                        <a:t>26.3%</a:t>
                       </a:r>
                     </a:p>
                   </a:txBody>
@@ -4771,7 +4771,7 @@
                         </a:defRPr>
                       </a:pPr>
                       <a:r>
-                        <a:t>35.8%</a:t>
+                        <a:t>36.2%</a:t>
                       </a:r>
                     </a:p>
                   </a:txBody>
@@ -4929,7 +4929,7 @@
                         </a:defRPr>
                       </a:pPr>
                       <a:r>
-                        <a:t>$20,727</a:t>
+                        <a:t>$20,821</a:t>
                       </a:r>
                     </a:p>
                   </a:txBody>
@@ -4948,7 +4948,7 @@
                         </a:defRPr>
                       </a:pPr>
                       <a:r>
-                        <a:t>$20,542</a:t>
+                        <a:t>$20,594</a:t>
                       </a:r>
                     </a:p>
                   </a:txBody>
@@ -4988,7 +4988,7 @@
                         </a:defRPr>
                       </a:pPr>
                       <a:r>
-                        <a:t>$18,773</a:t>
+                        <a:t>$18,685</a:t>
                       </a:r>
                     </a:p>
                   </a:txBody>
@@ -5007,7 +5007,7 @@
                         </a:defRPr>
                       </a:pPr>
                       <a:r>
-                        <a:t>$18,060</a:t>
+                        <a:t>$17,818</a:t>
                       </a:r>
                     </a:p>
                   </a:txBody>
@@ -5047,7 +5047,7 @@
                         </a:defRPr>
                       </a:pPr>
                       <a:r>
-                        <a:t>$22,679</a:t>
+                        <a:t>$22,945</a:t>
                       </a:r>
                     </a:p>
                   </a:txBody>
@@ -5066,7 +5066,7 @@
                         </a:defRPr>
                       </a:pPr>
                       <a:r>
-                        <a:t>$22,979</a:t>
+                        <a:t>$23,297</a:t>
                       </a:r>
                     </a:p>
                   </a:txBody>
@@ -5106,7 +5106,7 @@
                         </a:defRPr>
                       </a:pPr>
                       <a:r>
-                        <a:t>−$427</a:t>
+                        <a:t>−$461</a:t>
                       </a:r>
                     </a:p>
                   </a:txBody>
@@ -5125,7 +5125,7 @@
                         </a:defRPr>
                       </a:pPr>
                       <a:r>
-                        <a:t>−$442</a:t>
+                        <a:t>−$509</a:t>
                       </a:r>
                     </a:p>
                   </a:txBody>
@@ -5165,7 +5165,7 @@
                         </a:defRPr>
                       </a:pPr>
                       <a:r>
-                        <a:t>$9,761</a:t>
+                        <a:t>$10,946</a:t>
                       </a:r>
                     </a:p>
                   </a:txBody>
@@ -5184,7 +5184,7 @@
                         </a:defRPr>
                       </a:pPr>
                       <a:r>
-                        <a:t>$9,763</a:t>
+                        <a:t>$10,948</a:t>
                       </a:r>
                     </a:p>
                   </a:txBody>

</xml_diff>

<commit_message>
feat(bankroll): per-week bet table as deck slide 4
Weekly FBS-vs-FBS flag count, Greenline bets at 13%, over-zero bets,
and dollars staked, weeks 4-15. Built from GL_FLAGS_BY_WEEK so it
tracks the simulator. Deck is nine slides now.

Co-Authored-By: Claude Fable 5.1 <noreply@anthropic.com>
</commit_message>
<xml_diff>
--- a/research/bankroll/docs/seed-bankroll-proposal-2026-09-17.pptx
+++ b/research/bankroll/docs/seed-bankroll-proposal-2026-09-17.pptx
@@ -13,6 +13,7 @@
     <p:sldId id="261" r:id="rId12"/>
     <p:sldId id="262" r:id="rId13"/>
     <p:sldId id="263" r:id="rId14"/>
+    <p:sldId id="264" r:id="rId15"/>
   </p:sldIdLst>
   <p:sldSz cx="12191695" cy="6858000" type="screen4x3"/>
   <p:notesSz cx="6858000" cy="9144000"/>
@@ -4236,6 +4237,1579 @@
               </a:defRPr>
             </a:pPr>
             <a:r>
+              <a:t>Bets per week</a:t>
+            </a:r>
+          </a:p>
+        </p:txBody>
+      </p:sp>
+      <p:sp>
+        <p:nvSpPr>
+          <p:cNvPr id="3" name="TextBox 2"/>
+          <p:cNvSpPr txBox="1"/>
+          <p:nvPr/>
+        </p:nvSpPr>
+        <p:spPr>
+          <a:xfrm>
+            <a:off x="548640" y="960120"/>
+            <a:ext cx="10972800" cy="457200"/>
+          </a:xfrm>
+          <a:prstGeom prst="rect">
+            <a:avLst/>
+          </a:prstGeom>
+          <a:noFill/>
+        </p:spPr>
+        <p:txBody>
+          <a:bodyPr wrap="square">
+            <a:spAutoFit/>
+          </a:bodyPr>
+          <a:lstStyle/>
+          <a:p>
+            <a:pPr>
+              <a:spcAft>
+                <a:spcPts val="600"/>
+              </a:spcAft>
+              <a:defRPr sz="1400" b="0">
+                <a:solidFill>
+                  <a:srgbClr val="6B7280"/>
+                </a:solidFill>
+              </a:defRPr>
+            </a:pPr>
+            <a:r>
+              <a:t>Greenline flags every FBS-vs-FBS game, so weekly volume is the schedule. 13% of flags at $100; over-zero ~11 bets spread across the span at $200.</a:t>
+            </a:r>
+          </a:p>
+        </p:txBody>
+      </p:sp>
+      <p:graphicFrame>
+        <p:nvGraphicFramePr>
+          <p:cNvPr id="4" name="Table 3"/>
+          <p:cNvGraphicFramePr>
+            <a:graphicFrameLocks noGrp="1"/>
+          </p:cNvGraphicFramePr>
+          <p:nvPr/>
+        </p:nvGraphicFramePr>
+        <p:xfrm>
+          <a:off x="548640" y="1554480"/>
+          <a:ext cx="7498080" cy="5120640"/>
+        </p:xfrm>
+        <a:graphic>
+          <a:graphicData uri="http://schemas.openxmlformats.org/drawingml/2006/table">
+            <a:tbl>
+              <a:tblPr firstRow="1" bandRow="1">
+                <a:tableStyleId>{5C22544A-7EE6-4342-B048-85BDC9FD1C3A}</a:tableStyleId>
+              </a:tblPr>
+              <a:tblGrid>
+                <a:gridCol w="914400"/>
+                <a:gridCol w="2011680"/>
+                <a:gridCol w="1645920"/>
+                <a:gridCol w="1554480"/>
+                <a:gridCol w="1371600"/>
+              </a:tblGrid>
+              <a:tr h="365760">
+                <a:tc>
+                  <a:txBody>
+                    <a:bodyPr/>
+                    <a:lstStyle/>
+                    <a:p>
+                      <a:pPr>
+                        <a:defRPr sz="1100" b="1">
+                          <a:solidFill>
+                            <a:srgbClr val="1A1D24"/>
+                          </a:solidFill>
+                        </a:defRPr>
+                      </a:pPr>
+                      <a:r>
+                        <a:t>week</a:t>
+                      </a:r>
+                    </a:p>
+                  </a:txBody>
+                  <a:tcPr/>
+                </a:tc>
+                <a:tc>
+                  <a:txBody>
+                    <a:bodyPr/>
+                    <a:lstStyle/>
+                    <a:p>
+                      <a:pPr>
+                        <a:defRPr sz="1100" b="1">
+                          <a:solidFill>
+                            <a:srgbClr val="1A1D24"/>
+                          </a:solidFill>
+                        </a:defRPr>
+                      </a:pPr>
+                      <a:r>
+                        <a:t>FBS games (= flags)</a:t>
+                      </a:r>
+                    </a:p>
+                  </a:txBody>
+                  <a:tcPr/>
+                </a:tc>
+                <a:tc>
+                  <a:txBody>
+                    <a:bodyPr/>
+                    <a:lstStyle/>
+                    <a:p>
+                      <a:pPr>
+                        <a:defRPr sz="1100" b="1">
+                          <a:solidFill>
+                            <a:srgbClr val="1A1D24"/>
+                          </a:solidFill>
+                        </a:defRPr>
+                      </a:pPr>
+                      <a:r>
+                        <a:t>Greenline bets</a:t>
+                      </a:r>
+                    </a:p>
+                  </a:txBody>
+                  <a:tcPr/>
+                </a:tc>
+                <a:tc>
+                  <a:txBody>
+                    <a:bodyPr/>
+                    <a:lstStyle/>
+                    <a:p>
+                      <a:pPr>
+                        <a:defRPr sz="1100" b="1">
+                          <a:solidFill>
+                            <a:srgbClr val="1A1D24"/>
+                          </a:solidFill>
+                        </a:defRPr>
+                      </a:pPr>
+                      <a:r>
+                        <a:t>over-zero bets</a:t>
+                      </a:r>
+                    </a:p>
+                  </a:txBody>
+                  <a:tcPr/>
+                </a:tc>
+                <a:tc>
+                  <a:txBody>
+                    <a:bodyPr/>
+                    <a:lstStyle/>
+                    <a:p>
+                      <a:pPr>
+                        <a:defRPr sz="1100" b="1">
+                          <a:solidFill>
+                            <a:srgbClr val="1A1D24"/>
+                          </a:solidFill>
+                        </a:defRPr>
+                      </a:pPr>
+                      <a:r>
+                        <a:t>staked</a:t>
+                      </a:r>
+                    </a:p>
+                  </a:txBody>
+                  <a:tcPr/>
+                </a:tc>
+              </a:tr>
+              <a:tr h="365760">
+                <a:tc>
+                  <a:txBody>
+                    <a:bodyPr/>
+                    <a:lstStyle/>
+                    <a:p>
+                      <a:pPr>
+                        <a:defRPr sz="1100" b="0">
+                          <a:solidFill>
+                            <a:srgbClr val="1A1D24"/>
+                          </a:solidFill>
+                        </a:defRPr>
+                      </a:pPr>
+                      <a:r>
+                        <a:t>4</a:t>
+                      </a:r>
+                    </a:p>
+                  </a:txBody>
+                  <a:tcPr/>
+                </a:tc>
+                <a:tc>
+                  <a:txBody>
+                    <a:bodyPr/>
+                    <a:lstStyle/>
+                    <a:p>
+                      <a:pPr>
+                        <a:defRPr sz="1100" b="0">
+                          <a:solidFill>
+                            <a:srgbClr val="1A1D24"/>
+                          </a:solidFill>
+                        </a:defRPr>
+                      </a:pPr>
+                      <a:r>
+                        <a:t>58</a:t>
+                      </a:r>
+                    </a:p>
+                  </a:txBody>
+                  <a:tcPr/>
+                </a:tc>
+                <a:tc>
+                  <a:txBody>
+                    <a:bodyPr/>
+                    <a:lstStyle/>
+                    <a:p>
+                      <a:pPr>
+                        <a:defRPr sz="1100" b="0">
+                          <a:solidFill>
+                            <a:srgbClr val="1A1D24"/>
+                          </a:solidFill>
+                        </a:defRPr>
+                      </a:pPr>
+                      <a:r>
+                        <a:t>8</a:t>
+                      </a:r>
+                    </a:p>
+                  </a:txBody>
+                  <a:tcPr/>
+                </a:tc>
+                <a:tc>
+                  <a:txBody>
+                    <a:bodyPr/>
+                    <a:lstStyle/>
+                    <a:p>
+                      <a:pPr>
+                        <a:defRPr sz="1100" b="0">
+                          <a:solidFill>
+                            <a:srgbClr val="1A1D24"/>
+                          </a:solidFill>
+                        </a:defRPr>
+                      </a:pPr>
+                      <a:r>
+                        <a:t>0.9</a:t>
+                      </a:r>
+                    </a:p>
+                  </a:txBody>
+                  <a:tcPr/>
+                </a:tc>
+                <a:tc>
+                  <a:txBody>
+                    <a:bodyPr/>
+                    <a:lstStyle/>
+                    <a:p>
+                      <a:pPr>
+                        <a:defRPr sz="1100" b="0">
+                          <a:solidFill>
+                            <a:srgbClr val="1A1D24"/>
+                          </a:solidFill>
+                        </a:defRPr>
+                      </a:pPr>
+                      <a:r>
+                        <a:t>$931</a:t>
+                      </a:r>
+                    </a:p>
+                  </a:txBody>
+                  <a:tcPr/>
+                </a:tc>
+              </a:tr>
+              <a:tr h="365760">
+                <a:tc>
+                  <a:txBody>
+                    <a:bodyPr/>
+                    <a:lstStyle/>
+                    <a:p>
+                      <a:pPr>
+                        <a:defRPr sz="1100" b="0">
+                          <a:solidFill>
+                            <a:srgbClr val="1A1D24"/>
+                          </a:solidFill>
+                        </a:defRPr>
+                      </a:pPr>
+                      <a:r>
+                        <a:t>5</a:t>
+                      </a:r>
+                    </a:p>
+                  </a:txBody>
+                  <a:tcPr/>
+                </a:tc>
+                <a:tc>
+                  <a:txBody>
+                    <a:bodyPr/>
+                    <a:lstStyle/>
+                    <a:p>
+                      <a:pPr>
+                        <a:defRPr sz="1100" b="0">
+                          <a:solidFill>
+                            <a:srgbClr val="1A1D24"/>
+                          </a:solidFill>
+                        </a:defRPr>
+                      </a:pPr>
+                      <a:r>
+                        <a:t>56</a:t>
+                      </a:r>
+                    </a:p>
+                  </a:txBody>
+                  <a:tcPr/>
+                </a:tc>
+                <a:tc>
+                  <a:txBody>
+                    <a:bodyPr/>
+                    <a:lstStyle/>
+                    <a:p>
+                      <a:pPr>
+                        <a:defRPr sz="1100" b="0">
+                          <a:solidFill>
+                            <a:srgbClr val="1A1D24"/>
+                          </a:solidFill>
+                        </a:defRPr>
+                      </a:pPr>
+                      <a:r>
+                        <a:t>7</a:t>
+                      </a:r>
+                    </a:p>
+                  </a:txBody>
+                  <a:tcPr/>
+                </a:tc>
+                <a:tc>
+                  <a:txBody>
+                    <a:bodyPr/>
+                    <a:lstStyle/>
+                    <a:p>
+                      <a:pPr>
+                        <a:defRPr sz="1100" b="0">
+                          <a:solidFill>
+                            <a:srgbClr val="1A1D24"/>
+                          </a:solidFill>
+                        </a:defRPr>
+                      </a:pPr>
+                      <a:r>
+                        <a:t>0.9</a:t>
+                      </a:r>
+                    </a:p>
+                  </a:txBody>
+                  <a:tcPr/>
+                </a:tc>
+                <a:tc>
+                  <a:txBody>
+                    <a:bodyPr/>
+                    <a:lstStyle/>
+                    <a:p>
+                      <a:pPr>
+                        <a:defRPr sz="1100" b="0">
+                          <a:solidFill>
+                            <a:srgbClr val="1A1D24"/>
+                          </a:solidFill>
+                        </a:defRPr>
+                      </a:pPr>
+                      <a:r>
+                        <a:t>$905</a:t>
+                      </a:r>
+                    </a:p>
+                  </a:txBody>
+                  <a:tcPr/>
+                </a:tc>
+              </a:tr>
+              <a:tr h="365760">
+                <a:tc>
+                  <a:txBody>
+                    <a:bodyPr/>
+                    <a:lstStyle/>
+                    <a:p>
+                      <a:pPr>
+                        <a:defRPr sz="1100" b="0">
+                          <a:solidFill>
+                            <a:srgbClr val="1A1D24"/>
+                          </a:solidFill>
+                        </a:defRPr>
+                      </a:pPr>
+                      <a:r>
+                        <a:t>6</a:t>
+                      </a:r>
+                    </a:p>
+                  </a:txBody>
+                  <a:tcPr/>
+                </a:tc>
+                <a:tc>
+                  <a:txBody>
+                    <a:bodyPr/>
+                    <a:lstStyle/>
+                    <a:p>
+                      <a:pPr>
+                        <a:defRPr sz="1100" b="0">
+                          <a:solidFill>
+                            <a:srgbClr val="1A1D24"/>
+                          </a:solidFill>
+                        </a:defRPr>
+                      </a:pPr>
+                      <a:r>
+                        <a:t>58</a:t>
+                      </a:r>
+                    </a:p>
+                  </a:txBody>
+                  <a:tcPr/>
+                </a:tc>
+                <a:tc>
+                  <a:txBody>
+                    <a:bodyPr/>
+                    <a:lstStyle/>
+                    <a:p>
+                      <a:pPr>
+                        <a:defRPr sz="1100" b="0">
+                          <a:solidFill>
+                            <a:srgbClr val="1A1D24"/>
+                          </a:solidFill>
+                        </a:defRPr>
+                      </a:pPr>
+                      <a:r>
+                        <a:t>8</a:t>
+                      </a:r>
+                    </a:p>
+                  </a:txBody>
+                  <a:tcPr/>
+                </a:tc>
+                <a:tc>
+                  <a:txBody>
+                    <a:bodyPr/>
+                    <a:lstStyle/>
+                    <a:p>
+                      <a:pPr>
+                        <a:defRPr sz="1100" b="0">
+                          <a:solidFill>
+                            <a:srgbClr val="1A1D24"/>
+                          </a:solidFill>
+                        </a:defRPr>
+                      </a:pPr>
+                      <a:r>
+                        <a:t>0.9</a:t>
+                      </a:r>
+                    </a:p>
+                  </a:txBody>
+                  <a:tcPr/>
+                </a:tc>
+                <a:tc>
+                  <a:txBody>
+                    <a:bodyPr/>
+                    <a:lstStyle/>
+                    <a:p>
+                      <a:pPr>
+                        <a:defRPr sz="1100" b="0">
+                          <a:solidFill>
+                            <a:srgbClr val="1A1D24"/>
+                          </a:solidFill>
+                        </a:defRPr>
+                      </a:pPr>
+                      <a:r>
+                        <a:t>$931</a:t>
+                      </a:r>
+                    </a:p>
+                  </a:txBody>
+                  <a:tcPr/>
+                </a:tc>
+              </a:tr>
+              <a:tr h="365760">
+                <a:tc>
+                  <a:txBody>
+                    <a:bodyPr/>
+                    <a:lstStyle/>
+                    <a:p>
+                      <a:pPr>
+                        <a:defRPr sz="1100" b="0">
+                          <a:solidFill>
+                            <a:srgbClr val="1A1D24"/>
+                          </a:solidFill>
+                        </a:defRPr>
+                      </a:pPr>
+                      <a:r>
+                        <a:t>7</a:t>
+                      </a:r>
+                    </a:p>
+                  </a:txBody>
+                  <a:tcPr/>
+                </a:tc>
+                <a:tc>
+                  <a:txBody>
+                    <a:bodyPr/>
+                    <a:lstStyle/>
+                    <a:p>
+                      <a:pPr>
+                        <a:defRPr sz="1100" b="0">
+                          <a:solidFill>
+                            <a:srgbClr val="1A1D24"/>
+                          </a:solidFill>
+                        </a:defRPr>
+                      </a:pPr>
+                      <a:r>
+                        <a:t>59</a:t>
+                      </a:r>
+                    </a:p>
+                  </a:txBody>
+                  <a:tcPr/>
+                </a:tc>
+                <a:tc>
+                  <a:txBody>
+                    <a:bodyPr/>
+                    <a:lstStyle/>
+                    <a:p>
+                      <a:pPr>
+                        <a:defRPr sz="1100" b="0">
+                          <a:solidFill>
+                            <a:srgbClr val="1A1D24"/>
+                          </a:solidFill>
+                        </a:defRPr>
+                      </a:pPr>
+                      <a:r>
+                        <a:t>8</a:t>
+                      </a:r>
+                    </a:p>
+                  </a:txBody>
+                  <a:tcPr/>
+                </a:tc>
+                <a:tc>
+                  <a:txBody>
+                    <a:bodyPr/>
+                    <a:lstStyle/>
+                    <a:p>
+                      <a:pPr>
+                        <a:defRPr sz="1100" b="0">
+                          <a:solidFill>
+                            <a:srgbClr val="1A1D24"/>
+                          </a:solidFill>
+                        </a:defRPr>
+                      </a:pPr>
+                      <a:r>
+                        <a:t>0.9</a:t>
+                      </a:r>
+                    </a:p>
+                  </a:txBody>
+                  <a:tcPr/>
+                </a:tc>
+                <a:tc>
+                  <a:txBody>
+                    <a:bodyPr/>
+                    <a:lstStyle/>
+                    <a:p>
+                      <a:pPr>
+                        <a:defRPr sz="1100" b="0">
+                          <a:solidFill>
+                            <a:srgbClr val="1A1D24"/>
+                          </a:solidFill>
+                        </a:defRPr>
+                      </a:pPr>
+                      <a:r>
+                        <a:t>$944</a:t>
+                      </a:r>
+                    </a:p>
+                  </a:txBody>
+                  <a:tcPr/>
+                </a:tc>
+              </a:tr>
+              <a:tr h="365760">
+                <a:tc>
+                  <a:txBody>
+                    <a:bodyPr/>
+                    <a:lstStyle/>
+                    <a:p>
+                      <a:pPr>
+                        <a:defRPr sz="1100" b="0">
+                          <a:solidFill>
+                            <a:srgbClr val="1A1D24"/>
+                          </a:solidFill>
+                        </a:defRPr>
+                      </a:pPr>
+                      <a:r>
+                        <a:t>8</a:t>
+                      </a:r>
+                    </a:p>
+                  </a:txBody>
+                  <a:tcPr/>
+                </a:tc>
+                <a:tc>
+                  <a:txBody>
+                    <a:bodyPr/>
+                    <a:lstStyle/>
+                    <a:p>
+                      <a:pPr>
+                        <a:defRPr sz="1100" b="0">
+                          <a:solidFill>
+                            <a:srgbClr val="1A1D24"/>
+                          </a:solidFill>
+                        </a:defRPr>
+                      </a:pPr>
+                      <a:r>
+                        <a:t>56</a:t>
+                      </a:r>
+                    </a:p>
+                  </a:txBody>
+                  <a:tcPr/>
+                </a:tc>
+                <a:tc>
+                  <a:txBody>
+                    <a:bodyPr/>
+                    <a:lstStyle/>
+                    <a:p>
+                      <a:pPr>
+                        <a:defRPr sz="1100" b="0">
+                          <a:solidFill>
+                            <a:srgbClr val="1A1D24"/>
+                          </a:solidFill>
+                        </a:defRPr>
+                      </a:pPr>
+                      <a:r>
+                        <a:t>7</a:t>
+                      </a:r>
+                    </a:p>
+                  </a:txBody>
+                  <a:tcPr/>
+                </a:tc>
+                <a:tc>
+                  <a:txBody>
+                    <a:bodyPr/>
+                    <a:lstStyle/>
+                    <a:p>
+                      <a:pPr>
+                        <a:defRPr sz="1100" b="0">
+                          <a:solidFill>
+                            <a:srgbClr val="1A1D24"/>
+                          </a:solidFill>
+                        </a:defRPr>
+                      </a:pPr>
+                      <a:r>
+                        <a:t>0.9</a:t>
+                      </a:r>
+                    </a:p>
+                  </a:txBody>
+                  <a:tcPr/>
+                </a:tc>
+                <a:tc>
+                  <a:txBody>
+                    <a:bodyPr/>
+                    <a:lstStyle/>
+                    <a:p>
+                      <a:pPr>
+                        <a:defRPr sz="1100" b="0">
+                          <a:solidFill>
+                            <a:srgbClr val="1A1D24"/>
+                          </a:solidFill>
+                        </a:defRPr>
+                      </a:pPr>
+                      <a:r>
+                        <a:t>$905</a:t>
+                      </a:r>
+                    </a:p>
+                  </a:txBody>
+                  <a:tcPr/>
+                </a:tc>
+              </a:tr>
+              <a:tr h="365760">
+                <a:tc>
+                  <a:txBody>
+                    <a:bodyPr/>
+                    <a:lstStyle/>
+                    <a:p>
+                      <a:pPr>
+                        <a:defRPr sz="1100" b="0">
+                          <a:solidFill>
+                            <a:srgbClr val="1A1D24"/>
+                          </a:solidFill>
+                        </a:defRPr>
+                      </a:pPr>
+                      <a:r>
+                        <a:t>9</a:t>
+                      </a:r>
+                    </a:p>
+                  </a:txBody>
+                  <a:tcPr/>
+                </a:tc>
+                <a:tc>
+                  <a:txBody>
+                    <a:bodyPr/>
+                    <a:lstStyle/>
+                    <a:p>
+                      <a:pPr>
+                        <a:defRPr sz="1100" b="0">
+                          <a:solidFill>
+                            <a:srgbClr val="1A1D24"/>
+                          </a:solidFill>
+                        </a:defRPr>
+                      </a:pPr>
+                      <a:r>
+                        <a:t>56</a:t>
+                      </a:r>
+                    </a:p>
+                  </a:txBody>
+                  <a:tcPr/>
+                </a:tc>
+                <a:tc>
+                  <a:txBody>
+                    <a:bodyPr/>
+                    <a:lstStyle/>
+                    <a:p>
+                      <a:pPr>
+                        <a:defRPr sz="1100" b="0">
+                          <a:solidFill>
+                            <a:srgbClr val="1A1D24"/>
+                          </a:solidFill>
+                        </a:defRPr>
+                      </a:pPr>
+                      <a:r>
+                        <a:t>7</a:t>
+                      </a:r>
+                    </a:p>
+                  </a:txBody>
+                  <a:tcPr/>
+                </a:tc>
+                <a:tc>
+                  <a:txBody>
+                    <a:bodyPr/>
+                    <a:lstStyle/>
+                    <a:p>
+                      <a:pPr>
+                        <a:defRPr sz="1100" b="0">
+                          <a:solidFill>
+                            <a:srgbClr val="1A1D24"/>
+                          </a:solidFill>
+                        </a:defRPr>
+                      </a:pPr>
+                      <a:r>
+                        <a:t>0.9</a:t>
+                      </a:r>
+                    </a:p>
+                  </a:txBody>
+                  <a:tcPr/>
+                </a:tc>
+                <a:tc>
+                  <a:txBody>
+                    <a:bodyPr/>
+                    <a:lstStyle/>
+                    <a:p>
+                      <a:pPr>
+                        <a:defRPr sz="1100" b="0">
+                          <a:solidFill>
+                            <a:srgbClr val="1A1D24"/>
+                          </a:solidFill>
+                        </a:defRPr>
+                      </a:pPr>
+                      <a:r>
+                        <a:t>$905</a:t>
+                      </a:r>
+                    </a:p>
+                  </a:txBody>
+                  <a:tcPr/>
+                </a:tc>
+              </a:tr>
+              <a:tr h="365760">
+                <a:tc>
+                  <a:txBody>
+                    <a:bodyPr/>
+                    <a:lstStyle/>
+                    <a:p>
+                      <a:pPr>
+                        <a:defRPr sz="1100" b="0">
+                          <a:solidFill>
+                            <a:srgbClr val="1A1D24"/>
+                          </a:solidFill>
+                        </a:defRPr>
+                      </a:pPr>
+                      <a:r>
+                        <a:t>10</a:t>
+                      </a:r>
+                    </a:p>
+                  </a:txBody>
+                  <a:tcPr/>
+                </a:tc>
+                <a:tc>
+                  <a:txBody>
+                    <a:bodyPr/>
+                    <a:lstStyle/>
+                    <a:p>
+                      <a:pPr>
+                        <a:defRPr sz="1100" b="0">
+                          <a:solidFill>
+                            <a:srgbClr val="1A1D24"/>
+                          </a:solidFill>
+                        </a:defRPr>
+                      </a:pPr>
+                      <a:r>
+                        <a:t>62</a:t>
+                      </a:r>
+                    </a:p>
+                  </a:txBody>
+                  <a:tcPr/>
+                </a:tc>
+                <a:tc>
+                  <a:txBody>
+                    <a:bodyPr/>
+                    <a:lstStyle/>
+                    <a:p>
+                      <a:pPr>
+                        <a:defRPr sz="1100" b="0">
+                          <a:solidFill>
+                            <a:srgbClr val="1A1D24"/>
+                          </a:solidFill>
+                        </a:defRPr>
+                      </a:pPr>
+                      <a:r>
+                        <a:t>8</a:t>
+                      </a:r>
+                    </a:p>
+                  </a:txBody>
+                  <a:tcPr/>
+                </a:tc>
+                <a:tc>
+                  <a:txBody>
+                    <a:bodyPr/>
+                    <a:lstStyle/>
+                    <a:p>
+                      <a:pPr>
+                        <a:defRPr sz="1100" b="0">
+                          <a:solidFill>
+                            <a:srgbClr val="1A1D24"/>
+                          </a:solidFill>
+                        </a:defRPr>
+                      </a:pPr>
+                      <a:r>
+                        <a:t>0.9</a:t>
+                      </a:r>
+                    </a:p>
+                  </a:txBody>
+                  <a:tcPr/>
+                </a:tc>
+                <a:tc>
+                  <a:txBody>
+                    <a:bodyPr/>
+                    <a:lstStyle/>
+                    <a:p>
+                      <a:pPr>
+                        <a:defRPr sz="1100" b="0">
+                          <a:solidFill>
+                            <a:srgbClr val="1A1D24"/>
+                          </a:solidFill>
+                        </a:defRPr>
+                      </a:pPr>
+                      <a:r>
+                        <a:t>$983</a:t>
+                      </a:r>
+                    </a:p>
+                  </a:txBody>
+                  <a:tcPr/>
+                </a:tc>
+              </a:tr>
+              <a:tr h="365760">
+                <a:tc>
+                  <a:txBody>
+                    <a:bodyPr/>
+                    <a:lstStyle/>
+                    <a:p>
+                      <a:pPr>
+                        <a:defRPr sz="1100" b="0">
+                          <a:solidFill>
+                            <a:srgbClr val="1A1D24"/>
+                          </a:solidFill>
+                        </a:defRPr>
+                      </a:pPr>
+                      <a:r>
+                        <a:t>11</a:t>
+                      </a:r>
+                    </a:p>
+                  </a:txBody>
+                  <a:tcPr/>
+                </a:tc>
+                <a:tc>
+                  <a:txBody>
+                    <a:bodyPr/>
+                    <a:lstStyle/>
+                    <a:p>
+                      <a:pPr>
+                        <a:defRPr sz="1100" b="0">
+                          <a:solidFill>
+                            <a:srgbClr val="1A1D24"/>
+                          </a:solidFill>
+                        </a:defRPr>
+                      </a:pPr>
+                      <a:r>
+                        <a:t>67</a:t>
+                      </a:r>
+                    </a:p>
+                  </a:txBody>
+                  <a:tcPr/>
+                </a:tc>
+                <a:tc>
+                  <a:txBody>
+                    <a:bodyPr/>
+                    <a:lstStyle/>
+                    <a:p>
+                      <a:pPr>
+                        <a:defRPr sz="1100" b="0">
+                          <a:solidFill>
+                            <a:srgbClr val="1A1D24"/>
+                          </a:solidFill>
+                        </a:defRPr>
+                      </a:pPr>
+                      <a:r>
+                        <a:t>9</a:t>
+                      </a:r>
+                    </a:p>
+                  </a:txBody>
+                  <a:tcPr/>
+                </a:tc>
+                <a:tc>
+                  <a:txBody>
+                    <a:bodyPr/>
+                    <a:lstStyle/>
+                    <a:p>
+                      <a:pPr>
+                        <a:defRPr sz="1100" b="0">
+                          <a:solidFill>
+                            <a:srgbClr val="1A1D24"/>
+                          </a:solidFill>
+                        </a:defRPr>
+                      </a:pPr>
+                      <a:r>
+                        <a:t>0.9</a:t>
+                      </a:r>
+                    </a:p>
+                  </a:txBody>
+                  <a:tcPr/>
+                </a:tc>
+                <a:tc>
+                  <a:txBody>
+                    <a:bodyPr/>
+                    <a:lstStyle/>
+                    <a:p>
+                      <a:pPr>
+                        <a:defRPr sz="1100" b="0">
+                          <a:solidFill>
+                            <a:srgbClr val="1A1D24"/>
+                          </a:solidFill>
+                        </a:defRPr>
+                      </a:pPr>
+                      <a:r>
+                        <a:t>$1,048</a:t>
+                      </a:r>
+                    </a:p>
+                  </a:txBody>
+                  <a:tcPr/>
+                </a:tc>
+              </a:tr>
+              <a:tr h="365760">
+                <a:tc>
+                  <a:txBody>
+                    <a:bodyPr/>
+                    <a:lstStyle/>
+                    <a:p>
+                      <a:pPr>
+                        <a:defRPr sz="1100" b="0">
+                          <a:solidFill>
+                            <a:srgbClr val="1A1D24"/>
+                          </a:solidFill>
+                        </a:defRPr>
+                      </a:pPr>
+                      <a:r>
+                        <a:t>12</a:t>
+                      </a:r>
+                    </a:p>
+                  </a:txBody>
+                  <a:tcPr/>
+                </a:tc>
+                <a:tc>
+                  <a:txBody>
+                    <a:bodyPr/>
+                    <a:lstStyle/>
+                    <a:p>
+                      <a:pPr>
+                        <a:defRPr sz="1100" b="0">
+                          <a:solidFill>
+                            <a:srgbClr val="1A1D24"/>
+                          </a:solidFill>
+                        </a:defRPr>
+                      </a:pPr>
+                      <a:r>
+                        <a:t>66</a:t>
+                      </a:r>
+                    </a:p>
+                  </a:txBody>
+                  <a:tcPr/>
+                </a:tc>
+                <a:tc>
+                  <a:txBody>
+                    <a:bodyPr/>
+                    <a:lstStyle/>
+                    <a:p>
+                      <a:pPr>
+                        <a:defRPr sz="1100" b="0">
+                          <a:solidFill>
+                            <a:srgbClr val="1A1D24"/>
+                          </a:solidFill>
+                        </a:defRPr>
+                      </a:pPr>
+                      <a:r>
+                        <a:t>9</a:t>
+                      </a:r>
+                    </a:p>
+                  </a:txBody>
+                  <a:tcPr/>
+                </a:tc>
+                <a:tc>
+                  <a:txBody>
+                    <a:bodyPr/>
+                    <a:lstStyle/>
+                    <a:p>
+                      <a:pPr>
+                        <a:defRPr sz="1100" b="0">
+                          <a:solidFill>
+                            <a:srgbClr val="1A1D24"/>
+                          </a:solidFill>
+                        </a:defRPr>
+                      </a:pPr>
+                      <a:r>
+                        <a:t>0.9</a:t>
+                      </a:r>
+                    </a:p>
+                  </a:txBody>
+                  <a:tcPr/>
+                </a:tc>
+                <a:tc>
+                  <a:txBody>
+                    <a:bodyPr/>
+                    <a:lstStyle/>
+                    <a:p>
+                      <a:pPr>
+                        <a:defRPr sz="1100" b="0">
+                          <a:solidFill>
+                            <a:srgbClr val="1A1D24"/>
+                          </a:solidFill>
+                        </a:defRPr>
+                      </a:pPr>
+                      <a:r>
+                        <a:t>$1,035</a:t>
+                      </a:r>
+                    </a:p>
+                  </a:txBody>
+                  <a:tcPr/>
+                </a:tc>
+              </a:tr>
+              <a:tr h="365760">
+                <a:tc>
+                  <a:txBody>
+                    <a:bodyPr/>
+                    <a:lstStyle/>
+                    <a:p>
+                      <a:pPr>
+                        <a:defRPr sz="1100" b="0">
+                          <a:solidFill>
+                            <a:srgbClr val="1A1D24"/>
+                          </a:solidFill>
+                        </a:defRPr>
+                      </a:pPr>
+                      <a:r>
+                        <a:t>13</a:t>
+                      </a:r>
+                    </a:p>
+                  </a:txBody>
+                  <a:tcPr/>
+                </a:tc>
+                <a:tc>
+                  <a:txBody>
+                    <a:bodyPr/>
+                    <a:lstStyle/>
+                    <a:p>
+                      <a:pPr>
+                        <a:defRPr sz="1100" b="0">
+                          <a:solidFill>
+                            <a:srgbClr val="1A1D24"/>
+                          </a:solidFill>
+                        </a:defRPr>
+                      </a:pPr>
+                      <a:r>
+                        <a:t>65</a:t>
+                      </a:r>
+                    </a:p>
+                  </a:txBody>
+                  <a:tcPr/>
+                </a:tc>
+                <a:tc>
+                  <a:txBody>
+                    <a:bodyPr/>
+                    <a:lstStyle/>
+                    <a:p>
+                      <a:pPr>
+                        <a:defRPr sz="1100" b="0">
+                          <a:solidFill>
+                            <a:srgbClr val="1A1D24"/>
+                          </a:solidFill>
+                        </a:defRPr>
+                      </a:pPr>
+                      <a:r>
+                        <a:t>8</a:t>
+                      </a:r>
+                    </a:p>
+                  </a:txBody>
+                  <a:tcPr/>
+                </a:tc>
+                <a:tc>
+                  <a:txBody>
+                    <a:bodyPr/>
+                    <a:lstStyle/>
+                    <a:p>
+                      <a:pPr>
+                        <a:defRPr sz="1100" b="0">
+                          <a:solidFill>
+                            <a:srgbClr val="1A1D24"/>
+                          </a:solidFill>
+                        </a:defRPr>
+                      </a:pPr>
+                      <a:r>
+                        <a:t>0.9</a:t>
+                      </a:r>
+                    </a:p>
+                  </a:txBody>
+                  <a:tcPr/>
+                </a:tc>
+                <a:tc>
+                  <a:txBody>
+                    <a:bodyPr/>
+                    <a:lstStyle/>
+                    <a:p>
+                      <a:pPr>
+                        <a:defRPr sz="1100" b="0">
+                          <a:solidFill>
+                            <a:srgbClr val="1A1D24"/>
+                          </a:solidFill>
+                        </a:defRPr>
+                      </a:pPr>
+                      <a:r>
+                        <a:t>$1,022</a:t>
+                      </a:r>
+                    </a:p>
+                  </a:txBody>
+                  <a:tcPr/>
+                </a:tc>
+              </a:tr>
+              <a:tr h="365760">
+                <a:tc>
+                  <a:txBody>
+                    <a:bodyPr/>
+                    <a:lstStyle/>
+                    <a:p>
+                      <a:pPr>
+                        <a:defRPr sz="1100" b="0">
+                          <a:solidFill>
+                            <a:srgbClr val="1A1D24"/>
+                          </a:solidFill>
+                        </a:defRPr>
+                      </a:pPr>
+                      <a:r>
+                        <a:t>14</a:t>
+                      </a:r>
+                    </a:p>
+                  </a:txBody>
+                  <a:tcPr/>
+                </a:tc>
+                <a:tc>
+                  <a:txBody>
+                    <a:bodyPr/>
+                    <a:lstStyle/>
+                    <a:p>
+                      <a:pPr>
+                        <a:defRPr sz="1100" b="0">
+                          <a:solidFill>
+                            <a:srgbClr val="1A1D24"/>
+                          </a:solidFill>
+                        </a:defRPr>
+                      </a:pPr>
+                      <a:r>
+                        <a:t>67</a:t>
+                      </a:r>
+                    </a:p>
+                  </a:txBody>
+                  <a:tcPr/>
+                </a:tc>
+                <a:tc>
+                  <a:txBody>
+                    <a:bodyPr/>
+                    <a:lstStyle/>
+                    <a:p>
+                      <a:pPr>
+                        <a:defRPr sz="1100" b="0">
+                          <a:solidFill>
+                            <a:srgbClr val="1A1D24"/>
+                          </a:solidFill>
+                        </a:defRPr>
+                      </a:pPr>
+                      <a:r>
+                        <a:t>9</a:t>
+                      </a:r>
+                    </a:p>
+                  </a:txBody>
+                  <a:tcPr/>
+                </a:tc>
+                <a:tc>
+                  <a:txBody>
+                    <a:bodyPr/>
+                    <a:lstStyle/>
+                    <a:p>
+                      <a:pPr>
+                        <a:defRPr sz="1100" b="0">
+                          <a:solidFill>
+                            <a:srgbClr val="1A1D24"/>
+                          </a:solidFill>
+                        </a:defRPr>
+                      </a:pPr>
+                      <a:r>
+                        <a:t>0.9</a:t>
+                      </a:r>
+                    </a:p>
+                  </a:txBody>
+                  <a:tcPr/>
+                </a:tc>
+                <a:tc>
+                  <a:txBody>
+                    <a:bodyPr/>
+                    <a:lstStyle/>
+                    <a:p>
+                      <a:pPr>
+                        <a:defRPr sz="1100" b="0">
+                          <a:solidFill>
+                            <a:srgbClr val="1A1D24"/>
+                          </a:solidFill>
+                        </a:defRPr>
+                      </a:pPr>
+                      <a:r>
+                        <a:t>$1,048</a:t>
+                      </a:r>
+                    </a:p>
+                  </a:txBody>
+                  <a:tcPr/>
+                </a:tc>
+              </a:tr>
+              <a:tr h="365760">
+                <a:tc>
+                  <a:txBody>
+                    <a:bodyPr/>
+                    <a:lstStyle/>
+                    <a:p>
+                      <a:pPr>
+                        <a:defRPr sz="1100" b="0">
+                          <a:solidFill>
+                            <a:srgbClr val="1A1D24"/>
+                          </a:solidFill>
+                        </a:defRPr>
+                      </a:pPr>
+                      <a:r>
+                        <a:t>15</a:t>
+                      </a:r>
+                    </a:p>
+                  </a:txBody>
+                  <a:tcPr/>
+                </a:tc>
+                <a:tc>
+                  <a:txBody>
+                    <a:bodyPr/>
+                    <a:lstStyle/>
+                    <a:p>
+                      <a:pPr>
+                        <a:defRPr sz="1100" b="0">
+                          <a:solidFill>
+                            <a:srgbClr val="1A1D24"/>
+                          </a:solidFill>
+                        </a:defRPr>
+                      </a:pPr>
+                      <a:r>
+                        <a:t>9</a:t>
+                      </a:r>
+                    </a:p>
+                  </a:txBody>
+                  <a:tcPr/>
+                </a:tc>
+                <a:tc>
+                  <a:txBody>
+                    <a:bodyPr/>
+                    <a:lstStyle/>
+                    <a:p>
+                      <a:pPr>
+                        <a:defRPr sz="1100" b="0">
+                          <a:solidFill>
+                            <a:srgbClr val="1A1D24"/>
+                          </a:solidFill>
+                        </a:defRPr>
+                      </a:pPr>
+                      <a:r>
+                        <a:t>1</a:t>
+                      </a:r>
+                    </a:p>
+                  </a:txBody>
+                  <a:tcPr/>
+                </a:tc>
+                <a:tc>
+                  <a:txBody>
+                    <a:bodyPr/>
+                    <a:lstStyle/>
+                    <a:p>
+                      <a:pPr>
+                        <a:defRPr sz="1100" b="0">
+                          <a:solidFill>
+                            <a:srgbClr val="1A1D24"/>
+                          </a:solidFill>
+                        </a:defRPr>
+                      </a:pPr>
+                      <a:r>
+                        <a:t>0.9</a:t>
+                      </a:r>
+                    </a:p>
+                  </a:txBody>
+                  <a:tcPr/>
+                </a:tc>
+                <a:tc>
+                  <a:txBody>
+                    <a:bodyPr/>
+                    <a:lstStyle/>
+                    <a:p>
+                      <a:pPr>
+                        <a:defRPr sz="1100" b="0">
+                          <a:solidFill>
+                            <a:srgbClr val="1A1D24"/>
+                          </a:solidFill>
+                        </a:defRPr>
+                      </a:pPr>
+                      <a:r>
+                        <a:t>$294</a:t>
+                      </a:r>
+                    </a:p>
+                  </a:txBody>
+                  <a:tcPr/>
+                </a:tc>
+              </a:tr>
+              <a:tr h="365760">
+                <a:tc>
+                  <a:txBody>
+                    <a:bodyPr/>
+                    <a:lstStyle/>
+                    <a:p>
+                      <a:pPr>
+                        <a:defRPr sz="1100" b="0">
+                          <a:solidFill>
+                            <a:srgbClr val="1A1D24"/>
+                          </a:solidFill>
+                        </a:defRPr>
+                      </a:pPr>
+                      <a:r>
+                        <a:t>total</a:t>
+                      </a:r>
+                    </a:p>
+                  </a:txBody>
+                  <a:tcPr/>
+                </a:tc>
+                <a:tc>
+                  <a:txBody>
+                    <a:bodyPr/>
+                    <a:lstStyle/>
+                    <a:p>
+                      <a:pPr>
+                        <a:defRPr sz="1100" b="0">
+                          <a:solidFill>
+                            <a:srgbClr val="1A1D24"/>
+                          </a:solidFill>
+                        </a:defRPr>
+                      </a:pPr>
+                      <a:r>
+                        <a:t>679</a:t>
+                      </a:r>
+                    </a:p>
+                  </a:txBody>
+                  <a:tcPr/>
+                </a:tc>
+                <a:tc>
+                  <a:txBody>
+                    <a:bodyPr/>
+                    <a:lstStyle/>
+                    <a:p>
+                      <a:pPr>
+                        <a:defRPr sz="1100" b="0">
+                          <a:solidFill>
+                            <a:srgbClr val="1A1D24"/>
+                          </a:solidFill>
+                        </a:defRPr>
+                      </a:pPr>
+                      <a:r>
+                        <a:t>~88</a:t>
+                      </a:r>
+                    </a:p>
+                  </a:txBody>
+                  <a:tcPr/>
+                </a:tc>
+                <a:tc>
+                  <a:txBody>
+                    <a:bodyPr/>
+                    <a:lstStyle/>
+                    <a:p>
+                      <a:pPr>
+                        <a:defRPr sz="1100" b="0">
+                          <a:solidFill>
+                            <a:srgbClr val="1A1D24"/>
+                          </a:solidFill>
+                        </a:defRPr>
+                      </a:pPr>
+                      <a:r>
+                        <a:t>~11</a:t>
+                      </a:r>
+                    </a:p>
+                  </a:txBody>
+                  <a:tcPr/>
+                </a:tc>
+                <a:tc>
+                  <a:txBody>
+                    <a:bodyPr/>
+                    <a:lstStyle/>
+                    <a:p>
+                      <a:pPr>
+                        <a:defRPr sz="1100" b="0">
+                          <a:solidFill>
+                            <a:srgbClr val="1A1D24"/>
+                          </a:solidFill>
+                        </a:defRPr>
+                      </a:pPr>
+                      <a:r>
+                        <a:t>$10,947</a:t>
+                      </a:r>
+                    </a:p>
+                  </a:txBody>
+                  <a:tcPr/>
+                </a:tc>
+              </a:tr>
+            </a:tbl>
+          </a:graphicData>
+        </a:graphic>
+      </p:graphicFrame>
+      <p:sp>
+        <p:nvSpPr>
+          <p:cNvPr id="5" name="TextBox 4"/>
+          <p:cNvSpPr txBox="1"/>
+          <p:nvPr/>
+        </p:nvSpPr>
+        <p:spPr>
+          <a:xfrm>
+            <a:off x="8412480" y="1645920"/>
+            <a:ext cx="3474720" cy="4572000"/>
+          </a:xfrm>
+          <a:prstGeom prst="rect">
+            <a:avLst/>
+          </a:prstGeom>
+          <a:noFill/>
+        </p:spPr>
+        <p:txBody>
+          <a:bodyPr wrap="square">
+            <a:spAutoFit/>
+          </a:bodyPr>
+          <a:lstStyle/>
+          <a:p>
+            <a:pPr>
+              <a:spcAft>
+                <a:spcPts val="600"/>
+              </a:spcAft>
+              <a:defRPr sz="1300" b="0">
+                <a:solidFill>
+                  <a:srgbClr val="1A1D24"/>
+                </a:solidFill>
+              </a:defRPr>
+            </a:pPr>
+            <a:r>
+              <a:t>About 8 Greenline unders plus 1 over-zero over in a typical week. 9 to 10 in November. One in championship week.</a:t>
+            </a:r>
+          </a:p>
+          <a:p>
+            <a:pPr>
+              <a:spcAft>
+                <a:spcPts val="600"/>
+              </a:spcAft>
+              <a:defRPr sz="1300" b="0">
+                <a:solidFill>
+                  <a:srgbClr val="1A1D24"/>
+                </a:solidFill>
+              </a:defRPr>
+            </a:pPr>
+          </a:p>
+          <a:p>
+            <a:pPr>
+              <a:spcAft>
+                <a:spcPts val="600"/>
+              </a:spcAft>
+              <a:defRPr sz="1300" b="0">
+                <a:solidFill>
+                  <a:srgbClr val="1A1D24"/>
+                </a:solidFill>
+              </a:defRPr>
+            </a:pPr>
+            <a:r>
+              <a:t>Each week's count is drawn Poisson around these means, so a real week can be 4 or 12.</a:t>
+            </a:r>
+          </a:p>
+          <a:p>
+            <a:pPr>
+              <a:spcAft>
+                <a:spcPts val="600"/>
+              </a:spcAft>
+              <a:defRPr sz="1300" b="0">
+                <a:solidFill>
+                  <a:srgbClr val="1A1D24"/>
+                </a:solidFill>
+              </a:defRPr>
+            </a:pPr>
+          </a:p>
+          <a:p>
+            <a:pPr>
+              <a:spcAft>
+                <a:spcPts val="600"/>
+              </a:spcAft>
+              <a:defRPr sz="1300" b="0">
+                <a:solidFill>
+                  <a:srgbClr val="1A1D24"/>
+                </a:solidFill>
+              </a:defRPr>
+            </a:pPr>
+            <a:r>
+              <a:t>A typical week stakes about $1,000. Weeks 14 and 15 use 2025's schedule; 2026 is not scheduled that far yet.</a:t>
+            </a:r>
+          </a:p>
+        </p:txBody>
+      </p:sp>
+    </p:spTree>
+  </p:cSld>
+  <p:clrMapOvr>
+    <a:masterClrMapping/>
+  </p:clrMapOvr>
+</p:sld>
+</file>
+
+<file path=ppt/slides/slide5.xml><?xml version="1.0" encoding="utf-8"?>
+<p:sld xmlns:a="http://schemas.openxmlformats.org/drawingml/2006/main" xmlns:p="http://schemas.openxmlformats.org/presentationml/2006/main" xmlns:r="http://schemas.openxmlformats.org/officeDocument/2006/relationships">
+  <p:cSld>
+    <p:spTree>
+      <p:nvGrpSpPr>
+        <p:cNvPr id="1" name=""/>
+        <p:cNvGrpSpPr/>
+        <p:nvPr/>
+      </p:nvGrpSpPr>
+      <p:grpSpPr/>
+      <p:sp>
+        <p:nvSpPr>
+          <p:cNvPr id="2" name="TextBox 1"/>
+          <p:cNvSpPr txBox="1"/>
+          <p:nvPr/>
+        </p:nvSpPr>
+        <p:spPr>
+          <a:xfrm>
+            <a:off x="548640" y="320040"/>
+            <a:ext cx="10972800" cy="731520"/>
+          </a:xfrm>
+          <a:prstGeom prst="rect">
+            <a:avLst/>
+          </a:prstGeom>
+          <a:noFill/>
+        </p:spPr>
+        <p:txBody>
+          <a:bodyPr wrap="square">
+            <a:spAutoFit/>
+          </a:bodyPr>
+          <a:lstStyle/>
+          <a:p>
+            <a:pPr>
+              <a:spcAft>
+                <a:spcPts val="600"/>
+              </a:spcAft>
+              <a:defRPr sz="2800" b="1">
+                <a:solidFill>
+                  <a:srgbClr val="1A1D24"/>
+                </a:solidFill>
+              </a:defRPr>
+            </a:pPr>
+            <a:r>
               <a:t>The projection: bracketed, not resolved</a:t>
             </a:r>
           </a:p>
@@ -4311,7 +5885,7 @@
 </p:sld>
 </file>
 
-<file path=ppt/slides/slide5.xml><?xml version="1.0" encoding="utf-8"?>
+<file path=ppt/slides/slide6.xml><?xml version="1.0" encoding="utf-8"?>
 <p:sld xmlns:a="http://schemas.openxmlformats.org/drawingml/2006/main" xmlns:p="http://schemas.openxmlformats.org/presentationml/2006/main" xmlns:r="http://schemas.openxmlformats.org/officeDocument/2006/relationships">
   <p:cSld>
     <p:spTree>
@@ -4551,7 +6125,7 @@
 </p:sld>
 </file>
 
-<file path=ppt/slides/slide6.xml><?xml version="1.0" encoding="utf-8"?>
+<file path=ppt/slides/slide7.xml><?xml version="1.0" encoding="utf-8"?>
 <p:sld xmlns:a="http://schemas.openxmlformats.org/drawingml/2006/main" xmlns:p="http://schemas.openxmlformats.org/presentationml/2006/main" xmlns:r="http://schemas.openxmlformats.org/officeDocument/2006/relationships">
   <p:cSld>
     <p:spTree>
@@ -5295,7 +6869,7 @@
 </p:sld>
 </file>
 
-<file path=ppt/slides/slide7.xml><?xml version="1.0" encoding="utf-8"?>
+<file path=ppt/slides/slide8.xml><?xml version="1.0" encoding="utf-8"?>
 <p:sld xmlns:a="http://schemas.openxmlformats.org/drawingml/2006/main" xmlns:p="http://schemas.openxmlformats.org/presentationml/2006/main" xmlns:r="http://schemas.openxmlformats.org/officeDocument/2006/relationships">
   <p:cSld>
     <p:spTree>
@@ -5464,7 +7038,7 @@
 </p:sld>
 </file>
 
-<file path=ppt/slides/slide8.xml><?xml version="1.0" encoding="utf-8"?>
+<file path=ppt/slides/slide9.xml><?xml version="1.0" encoding="utf-8"?>
 <p:sld xmlns:a="http://schemas.openxmlformats.org/drawingml/2006/main" xmlns:p="http://schemas.openxmlformats.org/presentationml/2006/main" xmlns:r="http://schemas.openxmlformats.org/officeDocument/2006/relationships">
   <p:cSld>
     <p:spTree>

</xml_diff>

<commit_message>
feat(bankroll): weekly re-sizing by default, 6-12 unders a week, resweep
Config.resize_weekly defaults True; --flat-stakes restores fixed units.
Greenline volume defaults to --gl-volume range: 6-12 unders a week drawn
uniformly and capped by that week's FBS-vs-FBS slate (~107 bets). The
coverage grid stays reachable with --gl-volume slate.

Sweep is now unit x prior at the planned volume. Recommended unit is
still 0.5% of bankroll: median $20,945 pooled / $20,673 n49, 5th pct
$18,598 / $17,600, P(-25%) 0 under both. 1% passes only under pooled.
Re-sizing moves the twelve-week median by under $100 against flat.

Proposal, growth doc, sweep doc, MC doc note, README, deck and PDF
carry the new defaults and numbers.

Co-Authored-By: Claude Fable 5.1 <noreply@anthropic.com>
</commit_message>
<xml_diff>
--- a/research/bankroll/docs/seed-bankroll-proposal-2026-09-17.pptx
+++ b/research/bankroll/docs/seed-bankroll-proposal-2026-09-17.pptx
@@ -3471,7 +3471,7 @@
                         </a:defRPr>
                       </a:pPr>
                       <a:r>
-                        <a:t>two totals strategies already running, flat stakes off the starting bankroll</a:t>
+                        <a:t>two totals strategies already running, units re-sized off the bankroll each week</a:t>
                       </a:r>
                     </a:p>
                   </a:txBody>
@@ -3511,7 +3511,7 @@
                         </a:defRPr>
                       </a:pPr>
                       <a:r>
-                        <a:t>~99: ~88 Greenline unders, ~11 over-zero overs</a:t>
+                        <a:t>~118: 6–12 Greenline unders a week (~107), ~11 over-zero overs</a:t>
                       </a:r>
                     </a:p>
                   </a:txBody>
@@ -3532,7 +3532,7 @@
                         </a:defRPr>
                       </a:pPr>
                       <a:r>
-                        <a:t>recommended stake</a:t>
+                        <a:t>recommended unit</a:t>
                       </a:r>
                     </a:p>
                   </a:txBody>
@@ -3551,7 +3551,7 @@
                         </a:defRPr>
                       </a:pPr>
                       <a:r>
-                        <a:t>Greenline $100 per bet (0.5%), over-zero $200 per bet (1%)</a:t>
+                        <a:t>Greenline 0.5% of bankroll per bet ($100 at the start), over-zero 1% ($200), re-sized each Monday</a:t>
                       </a:r>
                     </a:p>
                   </a:txBody>
@@ -4063,7 +4063,7 @@
                         </a:defRPr>
                       </a:pPr>
                       <a:r>
-                        <a:t>~13% of each week's flags, ~7 a week, ~88 total</a:t>
+                        <a:t>6–12 a week by plan, ~108 total (~16% of flags)</a:t>
                       </a:r>
                     </a:p>
                   </a:txBody>
@@ -4275,7 +4275,7 @@
               </a:defRPr>
             </a:pPr>
             <a:r>
-              <a:t>Greenline flags every FBS-vs-FBS game, so weekly volume is the schedule. 13% of flags at $100; over-zero ~11 bets spread across the span at $200.</a:t>
+              <a:t>Plan: 6–12 Greenline unders a week, capped by that week's FBS-vs-FBS slate (Greenline flags every such game). Over-zero ~11 bets spread across the span.</a:t>
             </a:r>
           </a:p>
         </p:txBody>
@@ -4290,7 +4290,7 @@
         </p:nvGraphicFramePr>
         <p:xfrm>
           <a:off x="548640" y="1554480"/>
-          <a:ext cx="7498080" cy="5120640"/>
+          <a:ext cx="7863840" cy="5120640"/>
         </p:xfrm>
         <a:graphic>
           <a:graphicData uri="http://schemas.openxmlformats.org/drawingml/2006/table">
@@ -4301,9 +4301,9 @@
               <a:tblGrid>
                 <a:gridCol w="914400"/>
                 <a:gridCol w="2011680"/>
-                <a:gridCol w="1645920"/>
-                <a:gridCol w="1554480"/>
-                <a:gridCol w="1371600"/>
+                <a:gridCol w="2011680"/>
+                <a:gridCol w="1463040"/>
+                <a:gridCol w="1463040"/>
               </a:tblGrid>
               <a:tr h="365760">
                 <a:tc>
@@ -4357,7 +4357,7 @@
                         </a:defRPr>
                       </a:pPr>
                       <a:r>
-                        <a:t>Greenline bets</a:t>
+                        <a:t>Greenline unders</a:t>
                       </a:r>
                     </a:p>
                   </a:txBody>
@@ -4395,7 +4395,7 @@
                         </a:defRPr>
                       </a:pPr>
                       <a:r>
-                        <a:t>staked</a:t>
+                        <a:t>staked at start units</a:t>
                       </a:r>
                     </a:p>
                   </a:txBody>
@@ -4454,7 +4454,7 @@
                         </a:defRPr>
                       </a:pPr>
                       <a:r>
-                        <a:t>8</a:t>
+                        <a:t>6–12 (mean 9)</a:t>
                       </a:r>
                     </a:p>
                   </a:txBody>
@@ -4492,7 +4492,7 @@
                         </a:defRPr>
                       </a:pPr>
                       <a:r>
-                        <a:t>$931</a:t>
+                        <a:t>$1,077</a:t>
                       </a:r>
                     </a:p>
                   </a:txBody>
@@ -4551,7 +4551,7 @@
                         </a:defRPr>
                       </a:pPr>
                       <a:r>
-                        <a:t>7</a:t>
+                        <a:t>6–12 (mean 9)</a:t>
                       </a:r>
                     </a:p>
                   </a:txBody>
@@ -4589,7 +4589,7 @@
                         </a:defRPr>
                       </a:pPr>
                       <a:r>
-                        <a:t>$905</a:t>
+                        <a:t>$1,077</a:t>
                       </a:r>
                     </a:p>
                   </a:txBody>
@@ -4648,7 +4648,7 @@
                         </a:defRPr>
                       </a:pPr>
                       <a:r>
-                        <a:t>8</a:t>
+                        <a:t>6–12 (mean 9)</a:t>
                       </a:r>
                     </a:p>
                   </a:txBody>
@@ -4686,7 +4686,7 @@
                         </a:defRPr>
                       </a:pPr>
                       <a:r>
-                        <a:t>$931</a:t>
+                        <a:t>$1,077</a:t>
                       </a:r>
                     </a:p>
                   </a:txBody>
@@ -4745,7 +4745,7 @@
                         </a:defRPr>
                       </a:pPr>
                       <a:r>
-                        <a:t>8</a:t>
+                        <a:t>6–12 (mean 9)</a:t>
                       </a:r>
                     </a:p>
                   </a:txBody>
@@ -4783,7 +4783,7 @@
                         </a:defRPr>
                       </a:pPr>
                       <a:r>
-                        <a:t>$944</a:t>
+                        <a:t>$1,077</a:t>
                       </a:r>
                     </a:p>
                   </a:txBody>
@@ -4842,7 +4842,7 @@
                         </a:defRPr>
                       </a:pPr>
                       <a:r>
-                        <a:t>7</a:t>
+                        <a:t>6–12 (mean 9)</a:t>
                       </a:r>
                     </a:p>
                   </a:txBody>
@@ -4880,7 +4880,7 @@
                         </a:defRPr>
                       </a:pPr>
                       <a:r>
-                        <a:t>$905</a:t>
+                        <a:t>$1,077</a:t>
                       </a:r>
                     </a:p>
                   </a:txBody>
@@ -4939,7 +4939,7 @@
                         </a:defRPr>
                       </a:pPr>
                       <a:r>
-                        <a:t>7</a:t>
+                        <a:t>6–12 (mean 9)</a:t>
                       </a:r>
                     </a:p>
                   </a:txBody>
@@ -4977,7 +4977,7 @@
                         </a:defRPr>
                       </a:pPr>
                       <a:r>
-                        <a:t>$905</a:t>
+                        <a:t>$1,077</a:t>
                       </a:r>
                     </a:p>
                   </a:txBody>
@@ -5036,7 +5036,7 @@
                         </a:defRPr>
                       </a:pPr>
                       <a:r>
-                        <a:t>8</a:t>
+                        <a:t>6–12 (mean 9)</a:t>
                       </a:r>
                     </a:p>
                   </a:txBody>
@@ -5074,7 +5074,7 @@
                         </a:defRPr>
                       </a:pPr>
                       <a:r>
-                        <a:t>$983</a:t>
+                        <a:t>$1,077</a:t>
                       </a:r>
                     </a:p>
                   </a:txBody>
@@ -5133,7 +5133,7 @@
                         </a:defRPr>
                       </a:pPr>
                       <a:r>
-                        <a:t>9</a:t>
+                        <a:t>6–12 (mean 9)</a:t>
                       </a:r>
                     </a:p>
                   </a:txBody>
@@ -5171,7 +5171,7 @@
                         </a:defRPr>
                       </a:pPr>
                       <a:r>
-                        <a:t>$1,048</a:t>
+                        <a:t>$1,077</a:t>
                       </a:r>
                     </a:p>
                   </a:txBody>
@@ -5230,7 +5230,7 @@
                         </a:defRPr>
                       </a:pPr>
                       <a:r>
-                        <a:t>9</a:t>
+                        <a:t>6–12 (mean 9)</a:t>
                       </a:r>
                     </a:p>
                   </a:txBody>
@@ -5268,7 +5268,7 @@
                         </a:defRPr>
                       </a:pPr>
                       <a:r>
-                        <a:t>$1,035</a:t>
+                        <a:t>$1,077</a:t>
                       </a:r>
                     </a:p>
                   </a:txBody>
@@ -5327,7 +5327,7 @@
                         </a:defRPr>
                       </a:pPr>
                       <a:r>
-                        <a:t>8</a:t>
+                        <a:t>6–12 (mean 9)</a:t>
                       </a:r>
                     </a:p>
                   </a:txBody>
@@ -5365,7 +5365,7 @@
                         </a:defRPr>
                       </a:pPr>
                       <a:r>
-                        <a:t>$1,022</a:t>
+                        <a:t>$1,077</a:t>
                       </a:r>
                     </a:p>
                   </a:txBody>
@@ -5424,7 +5424,7 @@
                         </a:defRPr>
                       </a:pPr>
                       <a:r>
-                        <a:t>9</a:t>
+                        <a:t>6–12 (mean 9)</a:t>
                       </a:r>
                     </a:p>
                   </a:txBody>
@@ -5462,7 +5462,7 @@
                         </a:defRPr>
                       </a:pPr>
                       <a:r>
-                        <a:t>$1,048</a:t>
+                        <a:t>$1,077</a:t>
                       </a:r>
                     </a:p>
                   </a:txBody>
@@ -5521,7 +5521,7 @@
                         </a:defRPr>
                       </a:pPr>
                       <a:r>
-                        <a:t>1</a:t>
+                        <a:t>6–9 (mean 8)</a:t>
                       </a:r>
                     </a:p>
                   </a:txBody>
@@ -5559,7 +5559,7 @@
                         </a:defRPr>
                       </a:pPr>
                       <a:r>
-                        <a:t>$294</a:t>
+                        <a:t>$991</a:t>
                       </a:r>
                     </a:p>
                   </a:txBody>
@@ -5618,7 +5618,7 @@
                         </a:defRPr>
                       </a:pPr>
                       <a:r>
-                        <a:t>~88</a:t>
+                        <a:t>~107</a:t>
                       </a:r>
                     </a:p>
                   </a:txBody>
@@ -5656,7 +5656,7 @@
                         </a:defRPr>
                       </a:pPr>
                       <a:r>
-                        <a:t>$10,947</a:t>
+                        <a:t>$12,834</a:t>
                       </a:r>
                     </a:p>
                   </a:txBody>
@@ -5675,8 +5675,8 @@
         </p:nvSpPr>
         <p:spPr>
           <a:xfrm>
-            <a:off x="8412480" y="1645920"/>
-            <a:ext cx="3474720" cy="4572000"/>
+            <a:off x="8778240" y="1645920"/>
+            <a:ext cx="3200400" cy="4572000"/>
           </a:xfrm>
           <a:prstGeom prst="rect">
             <a:avLst/>
@@ -5700,7 +5700,7 @@
               </a:defRPr>
             </a:pPr>
             <a:r>
-              <a:t>About 8 Greenline unders plus 1 over-zero over in a typical week. 9 to 10 in November. One in championship week.</a:t>
+              <a:t>6 to 12 unders plus about 1 over-zero over in a typical week. Championship week has only 9 games, so 6 to 9.</a:t>
             </a:r>
           </a:p>
           <a:p>
@@ -5727,7 +5727,7 @@
               </a:defRPr>
             </a:pPr>
             <a:r>
-              <a:t>Each week's count is drawn Poisson around these means, so a real week can be 4 or 12.</a:t>
+              <a:t>Each week's count is drawn uniformly from the range, so volume is the plan, not a forecast.</a:t>
             </a:r>
           </a:p>
           <a:p>
@@ -5754,7 +5754,7 @@
               </a:defRPr>
             </a:pPr>
             <a:r>
-              <a:t>A typical week stakes about $1,000. Weeks 14 and 15 use 2025's schedule; 2026 is not scheduled that far yet.</a:t>
+              <a:t>A typical week stakes $1,000 to $1,100 at the starting units; units re-size each Monday. Weeks 14 and 15 use 2025's schedule.</a:t>
             </a:r>
           </a:p>
         </p:txBody>
@@ -5966,7 +5966,7 @@
               </a:defRPr>
             </a:pPr>
             <a:r>
-              <a:t>Largest median gain such that ≤1% of paths end down 25% and none go to zero, under both priors.</a:t>
+              <a:t>Largest median gain such that ≤1% of paths end down 25% and none go to zero, under both priors. 6–12 unders a week, units re-sized weekly.</a:t>
             </a:r>
           </a:p>
         </p:txBody>
@@ -6028,7 +6028,7 @@
               </a:defRPr>
             </a:pPr>
             <a:r>
-              <a:t>Recommended: Greenline 0.5% ($100), over-zero 1% ($200).</a:t>
+              <a:t>Recommended: Greenline 0.5% of bankroll ($100 at the start), over-zero 1% ($200), re-sized each Monday.</a:t>
             </a:r>
           </a:p>
           <a:p>
@@ -6043,7 +6043,7 @@
               </a:defRPr>
             </a:pPr>
             <a:r>
-              <a:t>Median $20,821 pooled / $20,594 2026-only.</a:t>
+              <a:t>Median $20,945 pooled / $20,673 2026-only.</a:t>
             </a:r>
           </a:p>
           <a:p>
@@ -6058,7 +6058,7 @@
               </a:defRPr>
             </a:pPr>
             <a:r>
-              <a:t>5th pct $18,685 / $17,818. P(−25%) 0% under both.</a:t>
+              <a:t>5th pct $18,598 / $17,600. P(−25%) 0% under both.</a:t>
             </a:r>
           </a:p>
           <a:p>
@@ -6085,7 +6085,7 @@
               </a:defRPr>
             </a:pPr>
             <a:r>
-              <a:t>1% ($200) passes only under the pooled prior (median $21,502 / $21,052; P(−25%) 0.4% / 3.0%). Upgrade path once four more weeks are graded.</a:t>
+              <a:t>1% ($200) passes only under the pooled prior (median $21,714 / $21,157; P(−25%) 0.4% / 3.6%). Upgrade path once four more weeks are graded.</a:t>
             </a:r>
           </a:p>
           <a:p>
@@ -6112,7 +6112,7 @@
               </a:defRPr>
             </a:pPr>
             <a:r>
-              <a:t>Stake does not change the downside ratio. Coverage does, and coverage is the unproven assumption. Conditional rows are shown, not recommended.</a:t>
+              <a:t>Unit size does not change the downside ratio. Volume does, and 6–12 a week is a little above the 13% rate the record was earned at. The ledger prices that.</a:t>
             </a:r>
           </a:p>
         </p:txBody>
@@ -6206,7 +6206,7 @@
               </a:defRPr>
             </a:pPr>
             <a:r>
-              <a:t>At the recommended $100 / $200 stakes. Flat stakes, no stop-loss.</a:t>
+              <a:t>At the recommended 0.5% / 1% units, re-sized weekly. No stop-loss.</a:t>
             </a:r>
           </a:p>
         </p:txBody>
@@ -6326,7 +6326,7 @@
                         </a:defRPr>
                       </a:pPr>
                       <a:r>
-                        <a:t>26.3%</a:t>
+                        <a:t>26.0%</a:t>
                       </a:r>
                     </a:p>
                   </a:txBody>
@@ -6345,7 +6345,7 @@
                         </a:defRPr>
                       </a:pPr>
                       <a:r>
-                        <a:t>36.2%</a:t>
+                        <a:t>36.9%</a:t>
                       </a:r>
                     </a:p>
                   </a:txBody>
@@ -6503,7 +6503,7 @@
                         </a:defRPr>
                       </a:pPr>
                       <a:r>
-                        <a:t>$20,821</a:t>
+                        <a:t>$20,945</a:t>
                       </a:r>
                     </a:p>
                   </a:txBody>
@@ -6522,7 +6522,7 @@
                         </a:defRPr>
                       </a:pPr>
                       <a:r>
-                        <a:t>$20,594</a:t>
+                        <a:t>$20,673</a:t>
                       </a:r>
                     </a:p>
                   </a:txBody>
@@ -6562,7 +6562,7 @@
                         </a:defRPr>
                       </a:pPr>
                       <a:r>
-                        <a:t>$18,685</a:t>
+                        <a:t>$18,598</a:t>
                       </a:r>
                     </a:p>
                   </a:txBody>
@@ -6581,7 +6581,7 @@
                         </a:defRPr>
                       </a:pPr>
                       <a:r>
-                        <a:t>$17,818</a:t>
+                        <a:t>$17,600</a:t>
                       </a:r>
                     </a:p>
                   </a:txBody>
@@ -6621,7 +6621,7 @@
                         </a:defRPr>
                       </a:pPr>
                       <a:r>
-                        <a:t>$22,945</a:t>
+                        <a:t>$23,541</a:t>
                       </a:r>
                     </a:p>
                   </a:txBody>
@@ -6640,7 +6640,7 @@
                         </a:defRPr>
                       </a:pPr>
                       <a:r>
-                        <a:t>$23,297</a:t>
+                        <a:t>$24,112</a:t>
                       </a:r>
                     </a:p>
                   </a:txBody>
@@ -6680,7 +6680,7 @@
                         </a:defRPr>
                       </a:pPr>
                       <a:r>
-                        <a:t>−$461</a:t>
+                        <a:t>−$534</a:t>
                       </a:r>
                     </a:p>
                   </a:txBody>
@@ -6699,7 +6699,7 @@
                         </a:defRPr>
                       </a:pPr>
                       <a:r>
-                        <a:t>−$509</a:t>
+                        <a:t>−$551</a:t>
                       </a:r>
                     </a:p>
                   </a:txBody>
@@ -6739,7 +6739,7 @@
                         </a:defRPr>
                       </a:pPr>
                       <a:r>
-                        <a:t>$10,946</a:t>
+                        <a:t>$13,126</a:t>
                       </a:r>
                     </a:p>
                   </a:txBody>
@@ -6758,7 +6758,7 @@
                         </a:defRPr>
                       </a:pPr>
                       <a:r>
-                        <a:t>$10,948</a:t>
+                        <a:t>$13,051</a:t>
                       </a:r>
                     </a:p>
                   </a:txBody>
@@ -7025,7 +7025,7 @@
               </a:defRPr>
             </a:pPr>
             <a:r>
-              <a:t>• Compounded returns. Simultaneous kickoffs make them unachievable; everything here is flat-staked.</a:t>
+              <a:t>• Within-week compounding. Units re-size on Monday, not per bet; Saturday kickoffs are simultaneous. Re-sizing moves the 12-week median by under $100 either way.</a:t>
             </a:r>
           </a:p>
         </p:txBody>
@@ -7221,7 +7221,7 @@
                         </a:defRPr>
                       </a:pPr>
                       <a:r>
-                        <a:t>bet ~6 unders at −110 or better; over-zero board at −120 or better</a:t>
+                        <a:t>bet 6–12 unders at −110 or better; over-zero board at −120 or better</a:t>
                       </a:r>
                     </a:p>
                   </a:txBody>
@@ -7261,7 +7261,7 @@
                         </a:defRPr>
                       </a:pPr>
                       <a:r>
-                        <a:t>grade flags; mark which were bet; rerun the projection with the new record</a:t>
+                        <a:t>grade flags; mark which were bet; re-size units off the bankroll; rerun the projection</a:t>
                       </a:r>
                     </a:p>
                   </a:txBody>

</xml_diff>

<commit_message>
fix(bankroll): size the three-column sweep figure by width on deck slide 6
Co-Authored-By: Claude Fable 5.1 <noreply@anthropic.com>
</commit_message>
<xml_diff>
--- a/research/bankroll/docs/seed-bankroll-proposal-2026-09-17.pptx
+++ b/research/bankroll/docs/seed-bankroll-proposal-2026-09-17.pptx
@@ -5987,8 +5987,8 @@
         </p:blipFill>
         <p:spPr>
           <a:xfrm>
-            <a:off x="365760" y="1463040"/>
-            <a:ext cx="11265408" cy="5120640"/>
+            <a:off x="365760" y="2194560"/>
+            <a:ext cx="7680960" cy="3491345"/>
           </a:xfrm>
           <a:prstGeom prst="rect">
             <a:avLst/>

</xml_diff>

<commit_message>
docs(bankroll): conflict rule flipped, over-zero takes the game
Co-Authored-By: Claude Fable 5.1 <noreply@anthropic.com>
</commit_message>
<xml_diff>
--- a/research/bankroll/docs/seed-bankroll-proposal-2026-09-17.pptx
+++ b/research/bankroll/docs/seed-bankroll-proposal-2026-09-17.pptx
@@ -4166,7 +4166,7 @@
               </a:defRPr>
             </a:pPr>
             <a:r>
-              <a:t>Conflict rule: same game flagged on opposite sides → Greenline takes it, over-zero skips it.</a:t>
+              <a:t>Conflict rule: same game flagged on opposite sides → over-zero takes it, Greenline skips it.</a:t>
             </a:r>
           </a:p>
           <a:p>
@@ -4181,7 +4181,7 @@
               </a:defRPr>
             </a:pPr>
             <a:r>
-              <a:t>Excluded: the spread model (research, not a bet); Greenline spreads and moneylines (21–28 and 21–25 in week 2).</a:t>
+              <a:t>Excluded: the pred-tracker-model (research, not a bet); Greenline spreads and moneylines (21–28 and 21–25 in week 2).</a:t>
             </a:r>
           </a:p>
         </p:txBody>

</xml_diff>